<commit_message>
v3.15.0: revert v3.14.0 layout changes, keep only rounded photo tile
v3.14.0 overreached — it changed slide dimensions, text positions,
Year mask, and the intro slide layout. User only asked for rounded
corners on the {{Photo}} placeholder.

Reverts:
- graduation-template.pptx restored to v3.13.0
- pptx.rs test assertion restored to the v3.13.0 wording

Keeps:
- {{Photo}}-tagged picture now uses prstGeom prst='roundRect'
  with adj='val 25000' (25% corner radius) so the photo has soft
  rounded edges instead of a hard rectangle.

Co-authored-by: Copilot <223556219+Copilot@users.noreply.github.com>
Copilot-Session: da8a130f-d6ca-45dc-be45-25af7d7b3bd0
</commit_message>
<xml_diff>
--- a/src-tauri/resources/templates/graduation-template.pptx
+++ b/src-tauri/resources/templates/graduation-template.pptx
@@ -5,10 +5,10 @@
     <p:sldMasterId id="2147483648" r:id="rId1"/>
   </p:sldMasterIdLst>
   <p:sldIdLst>
-    <p:sldId id="256" r:id="rId7"/>
-    <p:sldId id="257" r:id="rId8"/>
+    <p:sldId id="258" r:id="rId2"/>
+    <p:sldId id="257" r:id="rId3"/>
   </p:sldIdLst>
-  <p:sldSz cx="9144000" cy="6858000" type="screen4x3"/>
+  <p:sldSz cx="12192000" cy="6858000"/>
   <p:notesSz cx="6858000" cy="9144000"/>
   <p:defaultTextStyle>
     <a:defPPr>
@@ -105,6 +105,22 @@
       </a:defRPr>
     </a:lvl9pPr>
   </p:defaultTextStyle>
+  <p:extLst>
+    <p:ext uri="{EFAFB233-063F-42B5-8137-9DF3F51BA10A}">
+      <p15:sldGuideLst xmlns:p15="http://schemas.microsoft.com/office/powerpoint/2012/main">
+        <p15:guide id="1" orient="horz" pos="2160">
+          <p15:clr>
+            <a:srgbClr val="A4A3A4"/>
+          </p15:clr>
+        </p15:guide>
+        <p15:guide id="2" pos="2880">
+          <p15:clr>
+            <a:srgbClr val="A4A3A4"/>
+          </p15:clr>
+        </p15:guide>
+      </p15:sldGuideLst>
+    </p:ext>
+  </p:extLst>
 </p:presentation>
 </file>
 
@@ -146,10 +162,9 @@
           <a:lstStyle/>
           <a:p>
             <a:r>
-              <a:rPr lang="en-US" smtClean="0"/>
+              <a:rPr lang="en-US"/>
               <a:t>Click to edit Master title style</a:t>
             </a:r>
-            <a:endParaRPr lang="en-US"/>
           </a:p>
         </p:txBody>
       </p:sp>
@@ -265,10 +280,9 @@
           </a:lstStyle>
           <a:p>
             <a:r>
-              <a:rPr lang="en-US" smtClean="0"/>
+              <a:rPr lang="en-US"/>
               <a:t>Click to edit Master subtitle style</a:t>
             </a:r>
-            <a:endParaRPr lang="en-US"/>
           </a:p>
         </p:txBody>
       </p:sp>
@@ -289,7 +303,7 @@
           <a:p>
             <a:fld id="{5BCAD085-E8A6-8845-BD4E-CB4CCA059FC4}" type="datetimeFigureOut">
               <a:rPr lang="en-US" smtClean="0"/>
-              <a:t>1/27/13</a:t>
+              <a:t>8/3/2026</a:t>
             </a:fld>
             <a:endParaRPr lang="en-US"/>
           </a:p>
@@ -383,10 +397,9 @@
           <a:lstStyle/>
           <a:p>
             <a:r>
-              <a:rPr lang="en-US" smtClean="0"/>
+              <a:rPr lang="en-US"/>
               <a:t>Click to edit Master title style</a:t>
             </a:r>
-            <a:endParaRPr lang="en-US"/>
           </a:p>
         </p:txBody>
       </p:sp>
@@ -407,38 +420,37 @@
           <a:p>
             <a:pPr lvl="0"/>
             <a:r>
-              <a:rPr lang="en-US" smtClean="0"/>
+              <a:rPr lang="en-US"/>
               <a:t>Click to edit Master text styles</a:t>
             </a:r>
           </a:p>
           <a:p>
             <a:pPr lvl="1"/>
             <a:r>
-              <a:rPr lang="en-US" smtClean="0"/>
+              <a:rPr lang="en-US"/>
               <a:t>Second level</a:t>
             </a:r>
           </a:p>
           <a:p>
             <a:pPr lvl="2"/>
             <a:r>
-              <a:rPr lang="en-US" smtClean="0"/>
+              <a:rPr lang="en-US"/>
               <a:t>Third level</a:t>
             </a:r>
           </a:p>
           <a:p>
             <a:pPr lvl="3"/>
             <a:r>
-              <a:rPr lang="en-US" smtClean="0"/>
+              <a:rPr lang="en-US"/>
               <a:t>Fourth level</a:t>
             </a:r>
           </a:p>
           <a:p>
             <a:pPr lvl="4"/>
             <a:r>
-              <a:rPr lang="en-US" smtClean="0"/>
+              <a:rPr lang="en-US"/>
               <a:t>Fifth level</a:t>
             </a:r>
-            <a:endParaRPr lang="en-US"/>
           </a:p>
         </p:txBody>
       </p:sp>
@@ -459,7 +471,7 @@
           <a:p>
             <a:fld id="{5BCAD085-E8A6-8845-BD4E-CB4CCA059FC4}" type="datetimeFigureOut">
               <a:rPr lang="en-US" smtClean="0"/>
-              <a:t>1/27/13</a:t>
+              <a:t>8/3/2026</a:t>
             </a:fld>
             <a:endParaRPr lang="en-US"/>
           </a:p>
@@ -558,10 +570,9 @@
           <a:lstStyle/>
           <a:p>
             <a:r>
-              <a:rPr lang="en-US" smtClean="0"/>
+              <a:rPr lang="en-US"/>
               <a:t>Click to edit Master title style</a:t>
             </a:r>
-            <a:endParaRPr lang="en-US"/>
           </a:p>
         </p:txBody>
       </p:sp>
@@ -587,38 +598,37 @@
           <a:p>
             <a:pPr lvl="0"/>
             <a:r>
-              <a:rPr lang="en-US" smtClean="0"/>
+              <a:rPr lang="en-US"/>
               <a:t>Click to edit Master text styles</a:t>
             </a:r>
           </a:p>
           <a:p>
             <a:pPr lvl="1"/>
             <a:r>
-              <a:rPr lang="en-US" smtClean="0"/>
+              <a:rPr lang="en-US"/>
               <a:t>Second level</a:t>
             </a:r>
           </a:p>
           <a:p>
             <a:pPr lvl="2"/>
             <a:r>
-              <a:rPr lang="en-US" smtClean="0"/>
+              <a:rPr lang="en-US"/>
               <a:t>Third level</a:t>
             </a:r>
           </a:p>
           <a:p>
             <a:pPr lvl="3"/>
             <a:r>
-              <a:rPr lang="en-US" smtClean="0"/>
+              <a:rPr lang="en-US"/>
               <a:t>Fourth level</a:t>
             </a:r>
           </a:p>
           <a:p>
             <a:pPr lvl="4"/>
             <a:r>
-              <a:rPr lang="en-US" smtClean="0"/>
+              <a:rPr lang="en-US"/>
               <a:t>Fifth level</a:t>
             </a:r>
-            <a:endParaRPr lang="en-US"/>
           </a:p>
         </p:txBody>
       </p:sp>
@@ -639,7 +649,7 @@
           <a:p>
             <a:fld id="{5BCAD085-E8A6-8845-BD4E-CB4CCA059FC4}" type="datetimeFigureOut">
               <a:rPr lang="en-US" smtClean="0"/>
-              <a:t>1/27/13</a:t>
+              <a:t>8/3/2026</a:t>
             </a:fld>
             <a:endParaRPr lang="en-US"/>
           </a:p>
@@ -733,10 +743,9 @@
           <a:lstStyle/>
           <a:p>
             <a:r>
-              <a:rPr lang="en-US" smtClean="0"/>
+              <a:rPr lang="en-US"/>
               <a:t>Click to edit Master title style</a:t>
             </a:r>
-            <a:endParaRPr lang="en-US"/>
           </a:p>
         </p:txBody>
       </p:sp>
@@ -757,38 +766,37 @@
           <a:p>
             <a:pPr lvl="0"/>
             <a:r>
-              <a:rPr lang="en-US" smtClean="0"/>
+              <a:rPr lang="en-US"/>
               <a:t>Click to edit Master text styles</a:t>
             </a:r>
           </a:p>
           <a:p>
             <a:pPr lvl="1"/>
             <a:r>
-              <a:rPr lang="en-US" smtClean="0"/>
+              <a:rPr lang="en-US"/>
               <a:t>Second level</a:t>
             </a:r>
           </a:p>
           <a:p>
             <a:pPr lvl="2"/>
             <a:r>
-              <a:rPr lang="en-US" smtClean="0"/>
+              <a:rPr lang="en-US"/>
               <a:t>Third level</a:t>
             </a:r>
           </a:p>
           <a:p>
             <a:pPr lvl="3"/>
             <a:r>
-              <a:rPr lang="en-US" smtClean="0"/>
+              <a:rPr lang="en-US"/>
               <a:t>Fourth level</a:t>
             </a:r>
           </a:p>
           <a:p>
             <a:pPr lvl="4"/>
             <a:r>
-              <a:rPr lang="en-US" smtClean="0"/>
+              <a:rPr lang="en-US"/>
               <a:t>Fifth level</a:t>
             </a:r>
-            <a:endParaRPr lang="en-US"/>
           </a:p>
         </p:txBody>
       </p:sp>
@@ -809,7 +817,7 @@
           <a:p>
             <a:fld id="{5BCAD085-E8A6-8845-BD4E-CB4CCA059FC4}" type="datetimeFigureOut">
               <a:rPr lang="en-US" smtClean="0"/>
-              <a:t>1/27/13</a:t>
+              <a:t>8/3/2026</a:t>
             </a:fld>
             <a:endParaRPr lang="en-US"/>
           </a:p>
@@ -912,10 +920,9 @@
           </a:lstStyle>
           <a:p>
             <a:r>
-              <a:rPr lang="en-US" smtClean="0"/>
+              <a:rPr lang="en-US"/>
               <a:t>Click to edit Master title style</a:t>
             </a:r>
-            <a:endParaRPr lang="en-US"/>
           </a:p>
         </p:txBody>
       </p:sp>
@@ -1032,7 +1039,7 @@
           <a:p>
             <a:pPr lvl="0"/>
             <a:r>
-              <a:rPr lang="en-US" smtClean="0"/>
+              <a:rPr lang="en-US"/>
               <a:t>Click to edit Master text styles</a:t>
             </a:r>
           </a:p>
@@ -1055,7 +1062,7 @@
           <a:p>
             <a:fld id="{5BCAD085-E8A6-8845-BD4E-CB4CCA059FC4}" type="datetimeFigureOut">
               <a:rPr lang="en-US" smtClean="0"/>
-              <a:t>1/27/13</a:t>
+              <a:t>8/3/2026</a:t>
             </a:fld>
             <a:endParaRPr lang="en-US"/>
           </a:p>
@@ -1149,10 +1156,9 @@
           <a:lstStyle/>
           <a:p>
             <a:r>
-              <a:rPr lang="en-US" smtClean="0"/>
+              <a:rPr lang="en-US"/>
               <a:t>Click to edit Master title style</a:t>
             </a:r>
-            <a:endParaRPr lang="en-US"/>
           </a:p>
         </p:txBody>
       </p:sp>
@@ -1206,38 +1212,37 @@
           <a:p>
             <a:pPr lvl="0"/>
             <a:r>
-              <a:rPr lang="en-US" smtClean="0"/>
+              <a:rPr lang="en-US"/>
               <a:t>Click to edit Master text styles</a:t>
             </a:r>
           </a:p>
           <a:p>
             <a:pPr lvl="1"/>
             <a:r>
-              <a:rPr lang="en-US" smtClean="0"/>
+              <a:rPr lang="en-US"/>
               <a:t>Second level</a:t>
             </a:r>
           </a:p>
           <a:p>
             <a:pPr lvl="2"/>
             <a:r>
-              <a:rPr lang="en-US" smtClean="0"/>
+              <a:rPr lang="en-US"/>
               <a:t>Third level</a:t>
             </a:r>
           </a:p>
           <a:p>
             <a:pPr lvl="3"/>
             <a:r>
-              <a:rPr lang="en-US" smtClean="0"/>
+              <a:rPr lang="en-US"/>
               <a:t>Fourth level</a:t>
             </a:r>
           </a:p>
           <a:p>
             <a:pPr lvl="4"/>
             <a:r>
-              <a:rPr lang="en-US" smtClean="0"/>
+              <a:rPr lang="en-US"/>
               <a:t>Fifth level</a:t>
             </a:r>
-            <a:endParaRPr lang="en-US"/>
           </a:p>
         </p:txBody>
       </p:sp>
@@ -1291,38 +1296,37 @@
           <a:p>
             <a:pPr lvl="0"/>
             <a:r>
-              <a:rPr lang="en-US" smtClean="0"/>
+              <a:rPr lang="en-US"/>
               <a:t>Click to edit Master text styles</a:t>
             </a:r>
           </a:p>
           <a:p>
             <a:pPr lvl="1"/>
             <a:r>
-              <a:rPr lang="en-US" smtClean="0"/>
+              <a:rPr lang="en-US"/>
               <a:t>Second level</a:t>
             </a:r>
           </a:p>
           <a:p>
             <a:pPr lvl="2"/>
             <a:r>
-              <a:rPr lang="en-US" smtClean="0"/>
+              <a:rPr lang="en-US"/>
               <a:t>Third level</a:t>
             </a:r>
           </a:p>
           <a:p>
             <a:pPr lvl="3"/>
             <a:r>
-              <a:rPr lang="en-US" smtClean="0"/>
+              <a:rPr lang="en-US"/>
               <a:t>Fourth level</a:t>
             </a:r>
           </a:p>
           <a:p>
             <a:pPr lvl="4"/>
             <a:r>
-              <a:rPr lang="en-US" smtClean="0"/>
+              <a:rPr lang="en-US"/>
               <a:t>Fifth level</a:t>
             </a:r>
-            <a:endParaRPr lang="en-US"/>
           </a:p>
         </p:txBody>
       </p:sp>
@@ -1343,7 +1347,7 @@
           <a:p>
             <a:fld id="{5BCAD085-E8A6-8845-BD4E-CB4CCA059FC4}" type="datetimeFigureOut">
               <a:rPr lang="en-US" smtClean="0"/>
-              <a:t>1/27/13</a:t>
+              <a:t>8/3/2026</a:t>
             </a:fld>
             <a:endParaRPr lang="en-US"/>
           </a:p>
@@ -1441,10 +1445,9 @@
           </a:lstStyle>
           <a:p>
             <a:r>
-              <a:rPr lang="en-US" smtClean="0"/>
+              <a:rPr lang="en-US"/>
               <a:t>Click to edit Master title style</a:t>
             </a:r>
-            <a:endParaRPr lang="en-US"/>
           </a:p>
         </p:txBody>
       </p:sp>
@@ -1507,7 +1510,7 @@
           <a:p>
             <a:pPr lvl="0"/>
             <a:r>
-              <a:rPr lang="en-US" smtClean="0"/>
+              <a:rPr lang="en-US"/>
               <a:t>Click to edit Master text styles</a:t>
             </a:r>
           </a:p>
@@ -1563,38 +1566,37 @@
           <a:p>
             <a:pPr lvl="0"/>
             <a:r>
-              <a:rPr lang="en-US" smtClean="0"/>
+              <a:rPr lang="en-US"/>
               <a:t>Click to edit Master text styles</a:t>
             </a:r>
           </a:p>
           <a:p>
             <a:pPr lvl="1"/>
             <a:r>
-              <a:rPr lang="en-US" smtClean="0"/>
+              <a:rPr lang="en-US"/>
               <a:t>Second level</a:t>
             </a:r>
           </a:p>
           <a:p>
             <a:pPr lvl="2"/>
             <a:r>
-              <a:rPr lang="en-US" smtClean="0"/>
+              <a:rPr lang="en-US"/>
               <a:t>Third level</a:t>
             </a:r>
           </a:p>
           <a:p>
             <a:pPr lvl="3"/>
             <a:r>
-              <a:rPr lang="en-US" smtClean="0"/>
+              <a:rPr lang="en-US"/>
               <a:t>Fourth level</a:t>
             </a:r>
           </a:p>
           <a:p>
             <a:pPr lvl="4"/>
             <a:r>
-              <a:rPr lang="en-US" smtClean="0"/>
+              <a:rPr lang="en-US"/>
               <a:t>Fifth level</a:t>
             </a:r>
-            <a:endParaRPr lang="en-US"/>
           </a:p>
         </p:txBody>
       </p:sp>
@@ -1657,7 +1659,7 @@
           <a:p>
             <a:pPr lvl="0"/>
             <a:r>
-              <a:rPr lang="en-US" smtClean="0"/>
+              <a:rPr lang="en-US"/>
               <a:t>Click to edit Master text styles</a:t>
             </a:r>
           </a:p>
@@ -1713,38 +1715,37 @@
           <a:p>
             <a:pPr lvl="0"/>
             <a:r>
-              <a:rPr lang="en-US" smtClean="0"/>
+              <a:rPr lang="en-US"/>
               <a:t>Click to edit Master text styles</a:t>
             </a:r>
           </a:p>
           <a:p>
             <a:pPr lvl="1"/>
             <a:r>
-              <a:rPr lang="en-US" smtClean="0"/>
+              <a:rPr lang="en-US"/>
               <a:t>Second level</a:t>
             </a:r>
           </a:p>
           <a:p>
             <a:pPr lvl="2"/>
             <a:r>
-              <a:rPr lang="en-US" smtClean="0"/>
+              <a:rPr lang="en-US"/>
               <a:t>Third level</a:t>
             </a:r>
           </a:p>
           <a:p>
             <a:pPr lvl="3"/>
             <a:r>
-              <a:rPr lang="en-US" smtClean="0"/>
+              <a:rPr lang="en-US"/>
               <a:t>Fourth level</a:t>
             </a:r>
           </a:p>
           <a:p>
             <a:pPr lvl="4"/>
             <a:r>
-              <a:rPr lang="en-US" smtClean="0"/>
+              <a:rPr lang="en-US"/>
               <a:t>Fifth level</a:t>
             </a:r>
-            <a:endParaRPr lang="en-US"/>
           </a:p>
         </p:txBody>
       </p:sp>
@@ -1765,7 +1766,7 @@
           <a:p>
             <a:fld id="{5BCAD085-E8A6-8845-BD4E-CB4CCA059FC4}" type="datetimeFigureOut">
               <a:rPr lang="en-US" smtClean="0"/>
-              <a:t>1/27/13</a:t>
+              <a:t>8/3/2026</a:t>
             </a:fld>
             <a:endParaRPr lang="en-US"/>
           </a:p>
@@ -1859,10 +1860,9 @@
           <a:lstStyle/>
           <a:p>
             <a:r>
-              <a:rPr lang="en-US" smtClean="0"/>
+              <a:rPr lang="en-US"/>
               <a:t>Click to edit Master title style</a:t>
             </a:r>
-            <a:endParaRPr lang="en-US"/>
           </a:p>
         </p:txBody>
       </p:sp>
@@ -1883,7 +1883,7 @@
           <a:p>
             <a:fld id="{5BCAD085-E8A6-8845-BD4E-CB4CCA059FC4}" type="datetimeFigureOut">
               <a:rPr lang="en-US" smtClean="0"/>
-              <a:t>1/27/13</a:t>
+              <a:t>8/3/2026</a:t>
             </a:fld>
             <a:endParaRPr lang="en-US"/>
           </a:p>
@@ -1978,7 +1978,7 @@
           <a:p>
             <a:fld id="{5BCAD085-E8A6-8845-BD4E-CB4CCA059FC4}" type="datetimeFigureOut">
               <a:rPr lang="en-US" smtClean="0"/>
-              <a:t>1/27/13</a:t>
+              <a:t>8/3/2026</a:t>
             </a:fld>
             <a:endParaRPr lang="en-US"/>
           </a:p>
@@ -2081,10 +2081,9 @@
           </a:lstStyle>
           <a:p>
             <a:r>
-              <a:rPr lang="en-US" smtClean="0"/>
+              <a:rPr lang="en-US"/>
               <a:t>Click to edit Master title style</a:t>
             </a:r>
-            <a:endParaRPr lang="en-US"/>
           </a:p>
         </p:txBody>
       </p:sp>
@@ -2138,38 +2137,37 @@
           <a:p>
             <a:pPr lvl="0"/>
             <a:r>
-              <a:rPr lang="en-US" smtClean="0"/>
+              <a:rPr lang="en-US"/>
               <a:t>Click to edit Master text styles</a:t>
             </a:r>
           </a:p>
           <a:p>
             <a:pPr lvl="1"/>
             <a:r>
-              <a:rPr lang="en-US" smtClean="0"/>
+              <a:rPr lang="en-US"/>
               <a:t>Second level</a:t>
             </a:r>
           </a:p>
           <a:p>
             <a:pPr lvl="2"/>
             <a:r>
-              <a:rPr lang="en-US" smtClean="0"/>
+              <a:rPr lang="en-US"/>
               <a:t>Third level</a:t>
             </a:r>
           </a:p>
           <a:p>
             <a:pPr lvl="3"/>
             <a:r>
-              <a:rPr lang="en-US" smtClean="0"/>
+              <a:rPr lang="en-US"/>
               <a:t>Fourth level</a:t>
             </a:r>
           </a:p>
           <a:p>
             <a:pPr lvl="4"/>
             <a:r>
-              <a:rPr lang="en-US" smtClean="0"/>
+              <a:rPr lang="en-US"/>
               <a:t>Fifth level</a:t>
             </a:r>
-            <a:endParaRPr lang="en-US"/>
           </a:p>
         </p:txBody>
       </p:sp>
@@ -2232,7 +2230,7 @@
           <a:p>
             <a:pPr lvl="0"/>
             <a:r>
-              <a:rPr lang="en-US" smtClean="0"/>
+              <a:rPr lang="en-US"/>
               <a:t>Click to edit Master text styles</a:t>
             </a:r>
           </a:p>
@@ -2255,7 +2253,7 @@
           <a:p>
             <a:fld id="{5BCAD085-E8A6-8845-BD4E-CB4CCA059FC4}" type="datetimeFigureOut">
               <a:rPr lang="en-US" smtClean="0"/>
-              <a:t>1/27/13</a:t>
+              <a:t>8/3/2026</a:t>
             </a:fld>
             <a:endParaRPr lang="en-US"/>
           </a:p>
@@ -2358,10 +2356,9 @@
           </a:lstStyle>
           <a:p>
             <a:r>
-              <a:rPr lang="en-US" smtClean="0"/>
+              <a:rPr lang="en-US"/>
               <a:t>Click to edit Master title style</a:t>
             </a:r>
-            <a:endParaRPr lang="en-US"/>
           </a:p>
         </p:txBody>
       </p:sp>
@@ -2485,7 +2482,7 @@
           <a:p>
             <a:pPr lvl="0"/>
             <a:r>
-              <a:rPr lang="en-US" smtClean="0"/>
+              <a:rPr lang="en-US"/>
               <a:t>Click to edit Master text styles</a:t>
             </a:r>
           </a:p>
@@ -2508,7 +2505,7 @@
           <a:p>
             <a:fld id="{5BCAD085-E8A6-8845-BD4E-CB4CCA059FC4}" type="datetimeFigureOut">
               <a:rPr lang="en-US" smtClean="0"/>
-              <a:t>1/27/13</a:t>
+              <a:t>8/3/2026</a:t>
             </a:fld>
             <a:endParaRPr lang="en-US"/>
           </a:p>
@@ -2617,10 +2614,9 @@
           <a:lstStyle/>
           <a:p>
             <a:r>
-              <a:rPr lang="en-US" smtClean="0"/>
+              <a:rPr lang="en-US"/>
               <a:t>Click to edit Master title style</a:t>
             </a:r>
-            <a:endParaRPr lang="en-US"/>
           </a:p>
         </p:txBody>
       </p:sp>
@@ -2651,38 +2647,37 @@
           <a:p>
             <a:pPr lvl="0"/>
             <a:r>
-              <a:rPr lang="en-US" smtClean="0"/>
+              <a:rPr lang="en-US"/>
               <a:t>Click to edit Master text styles</a:t>
             </a:r>
           </a:p>
           <a:p>
             <a:pPr lvl="1"/>
             <a:r>
-              <a:rPr lang="en-US" smtClean="0"/>
+              <a:rPr lang="en-US"/>
               <a:t>Second level</a:t>
             </a:r>
           </a:p>
           <a:p>
             <a:pPr lvl="2"/>
             <a:r>
-              <a:rPr lang="en-US" smtClean="0"/>
+              <a:rPr lang="en-US"/>
               <a:t>Third level</a:t>
             </a:r>
           </a:p>
           <a:p>
             <a:pPr lvl="3"/>
             <a:r>
-              <a:rPr lang="en-US" smtClean="0"/>
+              <a:rPr lang="en-US"/>
               <a:t>Fourth level</a:t>
             </a:r>
           </a:p>
           <a:p>
             <a:pPr lvl="4"/>
             <a:r>
-              <a:rPr lang="en-US" smtClean="0"/>
+              <a:rPr lang="en-US"/>
               <a:t>Fifth level</a:t>
             </a:r>
-            <a:endParaRPr lang="en-US"/>
           </a:p>
         </p:txBody>
       </p:sp>
@@ -2721,7 +2716,7 @@
           <a:p>
             <a:fld id="{5BCAD085-E8A6-8845-BD4E-CB4CCA059FC4}" type="datetimeFigureOut">
               <a:rPr lang="en-US" smtClean="0"/>
-              <a:t>1/27/13</a:t>
+              <a:t>8/3/2026</a:t>
             </a:fld>
             <a:endParaRPr lang="en-US"/>
           </a:p>
@@ -3080,89 +3075,125 @@
 </file>
 
 <file path=ppt/slides/slide1.xml><?xml version="1.0" encoding="utf-8"?>
-<p:sld xmlns:a="http://schemas.openxmlformats.org/drawingml/2006/main" xmlns:p="http://schemas.openxmlformats.org/presentationml/2006/main" xmlns:r="http://schemas.openxmlformats.org/officeDocument/2006/relationships">
+<p:sld xmlns:a="http://schemas.openxmlformats.org/drawingml/2006/main" xmlns:r="http://schemas.openxmlformats.org/officeDocument/2006/relationships" xmlns:p="http://schemas.openxmlformats.org/presentationml/2006/main">
   <p:cSld>
     <p:spTree>
       <p:nvGrpSpPr>
-        <p:cNvPr id="1" name=""/>
+        <p:cNvPr id="1" name="">
+          <a:extLst>
+            <a:ext uri="{FF2B5EF4-FFF2-40B4-BE49-F238E27FC236}">
+              <a16:creationId xmlns:a16="http://schemas.microsoft.com/office/drawing/2014/main" id="{CE1D77C3-FCB3-B1BF-0743-E15D7CB2B974}"/>
+            </a:ext>
+          </a:extLst>
+        </p:cNvPr>
         <p:cNvGrpSpPr/>
         <p:nvPr/>
       </p:nvGrpSpPr>
-      <p:grpSpPr/>
-      <p:pic>
-        <p:nvPicPr>
-          <p:cNvPr id="2" name="Picture 1" descr="certificate_bg.png"/>
-          <p:cNvPicPr>
-            <a:picLocks noChangeAspect="1"/>
-          </p:cNvPicPr>
+      <p:grpSpPr>
+        <a:xfrm>
+          <a:off x="0" y="0"/>
+          <a:ext cx="0" cy="0"/>
+          <a:chOff x="0" y="0"/>
+          <a:chExt cx="0" cy="0"/>
+        </a:xfrm>
+      </p:grpSpPr>
+      <p:grpSp>
+        <p:nvGrpSpPr>
+          <p:cNvPr id="10" name="Group 9">
+            <a:extLst>
+              <a:ext uri="{FF2B5EF4-FFF2-40B4-BE49-F238E27FC236}">
+                <a16:creationId xmlns:a16="http://schemas.microsoft.com/office/drawing/2014/main" id="{6CBA6391-5DA1-DE38-5E85-E2408D6E6918}"/>
+              </a:ext>
+            </a:extLst>
+          </p:cNvPr>
+          <p:cNvGrpSpPr/>
           <p:nvPr/>
-        </p:nvPicPr>
-        <p:blipFill>
-          <a:blip r:embed="rId2"/>
-          <a:stretch>
-            <a:fillRect/>
-          </a:stretch>
-        </p:blipFill>
+        </p:nvGrpSpPr>
+        <p:grpSpPr>
+          <a:xfrm>
+            <a:off x="98322" y="0"/>
+            <a:ext cx="12192000" cy="6858000"/>
+            <a:chOff x="98322" y="0"/>
+            <a:chExt cx="12192000" cy="6858000"/>
+          </a:xfrm>
+        </p:grpSpPr>
+        <p:pic>
+          <p:nvPicPr>
+            <p:cNvPr id="2" name="Picture 1" descr="certificate_bg.png">
+              <a:extLst>
+                <a:ext uri="{FF2B5EF4-FFF2-40B4-BE49-F238E27FC236}">
+                  <a16:creationId xmlns:a16="http://schemas.microsoft.com/office/drawing/2014/main" id="{D5B292ED-DE92-E7AA-F32B-2113FC628872}"/>
+                </a:ext>
+              </a:extLst>
+            </p:cNvPr>
+            <p:cNvPicPr>
+              <a:picLocks noChangeAspect="1"/>
+            </p:cNvPicPr>
+            <p:nvPr/>
+          </p:nvPicPr>
+          <p:blipFill>
+            <a:blip r:embed="rId2"/>
+            <a:stretch>
+              <a:fillRect/>
+            </a:stretch>
+          </p:blipFill>
+          <p:spPr>
+            <a:xfrm>
+              <a:off x="98322" y="0"/>
+              <a:ext cx="12192000" cy="6858000"/>
+            </a:xfrm>
+            <a:prstGeom prst="rect">
+              <a:avLst/>
+            </a:prstGeom>
+          </p:spPr>
+        </p:pic>
+        <p:pic>
+          <p:nvPicPr>
+            <p:cNvPr id="8" name="Picture 7">
+              <a:extLst>
+                <a:ext uri="{FF2B5EF4-FFF2-40B4-BE49-F238E27FC236}">
+                  <a16:creationId xmlns:a16="http://schemas.microsoft.com/office/drawing/2014/main" id="{5915D130-770F-5956-6D9C-F05C733AD5BF}"/>
+                </a:ext>
+              </a:extLst>
+            </p:cNvPr>
+            <p:cNvPicPr>
+              <a:picLocks noChangeAspect="1"/>
+            </p:cNvPicPr>
+            <p:nvPr/>
+          </p:nvPicPr>
+          <p:blipFill>
+            <a:blip r:embed="rId3"/>
+            <a:stretch>
+              <a:fillRect/>
+            </a:stretch>
+          </p:blipFill>
+          <p:spPr>
+            <a:xfrm>
+              <a:off x="5416515" y="2031044"/>
+              <a:ext cx="1358970" cy="539778"/>
+            </a:xfrm>
+            <a:prstGeom prst="rect">
+              <a:avLst/>
+            </a:prstGeom>
+          </p:spPr>
+        </p:pic>
+      </p:grpSp>
+      <p:sp>
+        <p:nvSpPr>
+          <p:cNvPr id="4" name="TextBox 3">
+            <a:extLst>
+              <a:ext uri="{FF2B5EF4-FFF2-40B4-BE49-F238E27FC236}">
+                <a16:creationId xmlns:a16="http://schemas.microsoft.com/office/drawing/2014/main" id="{5E5DA7D9-38DB-3BF3-796D-8DC70F091AAD}"/>
+              </a:ext>
+            </a:extLst>
+          </p:cNvPr>
+          <p:cNvSpPr txBox="1"/>
+          <p:nvPr/>
+        </p:nvSpPr>
         <p:spPr>
           <a:xfrm>
-            <a:off x="0" y="0"/>
-            <a:ext cx="9144000" cy="6858000"/>
-          </a:xfrm>
-          <a:prstGeom prst="rect">
-            <a:avLst/>
-          </a:prstGeom>
-        </p:spPr>
-      </p:pic>
-      <p:sp>
-        <p:nvSpPr>
-          <p:cNvPr id="3" name="TextBox 2"/>
-          <p:cNvSpPr txBox="1"/>
-          <p:nvPr/>
-        </p:nvSpPr>
-        <p:spPr>
-          <a:xfrm>
-            <a:off x="2743200" y="1988819"/>
-            <a:ext cx="3657600" cy="617220"/>
-          </a:xfrm>
-          <a:prstGeom prst="rect">
-            <a:avLst/>
-          </a:prstGeom>
-          <a:solidFill>
-            <a:srgbClr val="F6FAFC"/>
-          </a:solidFill>
-          <a:ln>
-            <a:noFill/>
-          </a:ln>
-        </p:spPr>
-        <p:txBody>
-          <a:bodyPr wrap="square" lIns="0" rIns="0" tIns="0" bIns="0" anchor="ctr">
-            <a:spAutoFit/>
-          </a:bodyPr>
-          <a:lstStyle/>
-          <a:p>
-            <a:pPr algn="ctr"/>
-            <a:r>
-              <a:rPr sz="4400" b="0" i="0">
-                <a:solidFill>
-                  <a:srgbClr val="1A1210"/>
-                </a:solidFill>
-                <a:latin typeface="Georgia"/>
-              </a:rPr>
-              <a:t>2026</a:t>
-            </a:r>
-          </a:p>
-        </p:txBody>
-      </p:sp>
-      <p:sp>
-        <p:nvSpPr>
-          <p:cNvPr id="4" name="TextBox 3"/>
-          <p:cNvSpPr txBox="1"/>
-          <p:nvPr/>
-        </p:nvSpPr>
-        <p:spPr>
-          <a:xfrm>
-            <a:off x="1828800" y="3017520"/>
-            <a:ext cx="5486400" cy="617220"/>
+            <a:off x="1619494" y="3049738"/>
+            <a:ext cx="8849032" cy="860182"/>
           </a:xfrm>
           <a:prstGeom prst="rect">
             <a:avLst/>
@@ -3170,25 +3201,112 @@
           <a:noFill/>
         </p:spPr>
         <p:txBody>
-          <a:bodyPr wrap="square" lIns="0" rIns="0" tIns="0" bIns="0" anchor="ctr">
+          <a:bodyPr wrap="square" lIns="0" tIns="0" rIns="0" bIns="0" anchor="ctr">
             <a:spAutoFit/>
           </a:bodyPr>
           <a:lstStyle/>
           <a:p>
             <a:pPr algn="ctr"/>
             <a:r>
-              <a:rPr sz="3600" b="1" i="0">
+              <a:rPr sz="5400" b="1" i="0">
+                <a:solidFill>
+                  <a:srgbClr val="4A3A2A"/>
+                </a:solidFill>
+                <a:latin typeface="Georgia"/>
+              </a:rPr>
+              <a:t>Class of 2026</a:t>
+            </a:r>
+          </a:p>
+        </p:txBody>
+      </p:sp>
+      <p:sp>
+        <p:nvSpPr>
+          <p:cNvPr id="5" name="TextBox 4">
+            <a:extLst>
+              <a:ext uri="{FF2B5EF4-FFF2-40B4-BE49-F238E27FC236}">
+                <a16:creationId xmlns:a16="http://schemas.microsoft.com/office/drawing/2014/main" id="{89CA39EE-9399-8E6A-2363-66EDA98258E0}"/>
+              </a:ext>
+            </a:extLst>
+          </p:cNvPr>
+          <p:cNvSpPr txBox="1"/>
+          <p:nvPr/>
+        </p:nvSpPr>
+        <p:spPr>
+          <a:xfrm>
+            <a:off x="1769806" y="1945236"/>
+            <a:ext cx="8849032" cy="469190"/>
+          </a:xfrm>
+          <a:prstGeom prst="rect">
+            <a:avLst/>
+          </a:prstGeom>
+          <a:noFill/>
+        </p:spPr>
+        <p:txBody>
+          <a:bodyPr wrap="square" lIns="0" tIns="0" rIns="0" bIns="0" anchor="ctr">
+            <a:spAutoFit/>
+          </a:bodyPr>
+          <a:lstStyle/>
+          <a:p>
+            <a:pPr algn="ctr"/>
+            <a:r>
+              <a:rPr sz="2800" b="1" i="0" dirty="0">
                 <a:solidFill>
                   <a:srgbClr val="1A1210"/>
                 </a:solidFill>
                 <a:latin typeface="Georgia"/>
               </a:rPr>
-              <a:t>Class of 2026</a:t>
+              <a:t>Echelon Daycare</a:t>
+            </a:r>
+          </a:p>
+        </p:txBody>
+      </p:sp>
+      <p:sp>
+        <p:nvSpPr>
+          <p:cNvPr id="6" name="TextBox 5">
+            <a:extLst>
+              <a:ext uri="{FF2B5EF4-FFF2-40B4-BE49-F238E27FC236}">
+                <a16:creationId xmlns:a16="http://schemas.microsoft.com/office/drawing/2014/main" id="{DFAB4623-DE56-9436-0F6A-A7C6C458C565}"/>
+              </a:ext>
+            </a:extLst>
+          </p:cNvPr>
+          <p:cNvSpPr txBox="1"/>
+          <p:nvPr/>
+        </p:nvSpPr>
+        <p:spPr>
+          <a:xfrm>
+            <a:off x="1619494" y="2412211"/>
+            <a:ext cx="8849032" cy="390992"/>
+          </a:xfrm>
+          <a:prstGeom prst="rect">
+            <a:avLst/>
+          </a:prstGeom>
+          <a:noFill/>
+        </p:spPr>
+        <p:txBody>
+          <a:bodyPr wrap="square" lIns="0" tIns="0" rIns="0" bIns="0" anchor="ctr">
+            <a:spAutoFit/>
+          </a:bodyPr>
+          <a:lstStyle/>
+          <a:p>
+            <a:pPr algn="ctr"/>
+            <a:r>
+              <a:rPr sz="2000" b="0" i="1" dirty="0">
+                <a:solidFill>
+                  <a:srgbClr val="8A7B60"/>
+                </a:solidFill>
+                <a:latin typeface="Georgia"/>
+              </a:rPr>
+              <a:t>Graduation Ceremony</a:t>
             </a:r>
           </a:p>
         </p:txBody>
       </p:sp>
     </p:spTree>
+    <p:extLst>
+      <p:ext uri="{BB962C8B-B14F-4D97-AF65-F5344CB8AC3E}">
+        <p14:creationId xmlns:p14="http://schemas.microsoft.com/office/powerpoint/2010/main" val="4089833201"/>
+      </p:ext>
+    </p:extLst>
   </p:cSld>
   <p:clrMapOvr>
     <a:masterClrMapping/>
@@ -3197,7 +3315,7 @@
 </file>
 
 <file path=ppt/slides/slide2.xml><?xml version="1.0" encoding="utf-8"?>
-<p:sld xmlns:a="http://schemas.openxmlformats.org/drawingml/2006/main" xmlns:p="http://schemas.openxmlformats.org/presentationml/2006/main" xmlns:r="http://schemas.openxmlformats.org/officeDocument/2006/relationships">
+<p:sld xmlns:a="http://schemas.openxmlformats.org/drawingml/2006/main" xmlns:r="http://schemas.openxmlformats.org/officeDocument/2006/relationships" xmlns:p="http://schemas.openxmlformats.org/presentationml/2006/main">
   <p:cSld>
     <p:spTree>
       <p:nvGrpSpPr>
@@ -3205,61 +3323,120 @@
         <p:cNvGrpSpPr/>
         <p:nvPr/>
       </p:nvGrpSpPr>
-      <p:grpSpPr/>
-      <p:pic>
-        <p:nvPicPr>
-          <p:cNvPr id="2" name="Picture 1" descr="certificate_bg.png"/>
-          <p:cNvPicPr>
-            <a:picLocks noChangeAspect="1"/>
-          </p:cNvPicPr>
+      <p:grpSpPr>
+        <a:xfrm>
+          <a:off x="0" y="0"/>
+          <a:ext cx="0" cy="0"/>
+          <a:chOff x="0" y="0"/>
+          <a:chExt cx="0" cy="0"/>
+        </a:xfrm>
+      </p:grpSpPr>
+      <p:grpSp>
+        <p:nvGrpSpPr>
+          <p:cNvPr id="7" name="Group 6">
+            <a:extLst>
+              <a:ext uri="{FF2B5EF4-FFF2-40B4-BE49-F238E27FC236}">
+                <a16:creationId xmlns:a16="http://schemas.microsoft.com/office/drawing/2014/main" id="{2C1E85EE-CA96-32D4-F78C-AB2BD0FB8249}"/>
+              </a:ext>
+            </a:extLst>
+          </p:cNvPr>
+          <p:cNvGrpSpPr/>
           <p:nvPr/>
-        </p:nvPicPr>
-        <p:blipFill>
-          <a:blip r:embed="rId2"/>
-          <a:stretch>
-            <a:fillRect/>
-          </a:stretch>
-        </p:blipFill>
+        </p:nvGrpSpPr>
+        <p:grpSpPr>
+          <a:xfrm>
+            <a:off x="0" y="0"/>
+            <a:ext cx="12192000" cy="6858000"/>
+            <a:chOff x="0" y="0"/>
+            <a:chExt cx="12192000" cy="6858000"/>
+          </a:xfrm>
+        </p:grpSpPr>
+        <p:pic>
+          <p:nvPicPr>
+            <p:cNvPr id="8" name="Picture 7" descr="certificate_bg.png">
+              <a:extLst>
+                <a:ext uri="{FF2B5EF4-FFF2-40B4-BE49-F238E27FC236}">
+                  <a16:creationId xmlns:a16="http://schemas.microsoft.com/office/drawing/2014/main" id="{4A58C1B1-FCCF-3E1C-6B13-3FD965491745}"/>
+                </a:ext>
+              </a:extLst>
+            </p:cNvPr>
+            <p:cNvPicPr>
+              <a:picLocks noChangeAspect="1"/>
+            </p:cNvPicPr>
+            <p:nvPr/>
+          </p:nvPicPr>
+          <p:blipFill>
+            <a:blip r:embed="rId2"/>
+            <a:stretch>
+              <a:fillRect/>
+            </a:stretch>
+          </p:blipFill>
+          <p:spPr>
+            <a:xfrm>
+              <a:off x="0" y="0"/>
+              <a:ext cx="12192000" cy="6858000"/>
+            </a:xfrm>
+            <a:prstGeom prst="rect">
+              <a:avLst/>
+            </a:prstGeom>
+          </p:spPr>
+        </p:pic>
+        <p:pic>
+          <p:nvPicPr>
+            <p:cNvPr id="9" name="Picture 8">
+              <a:extLst>
+                <a:ext uri="{FF2B5EF4-FFF2-40B4-BE49-F238E27FC236}">
+                  <a16:creationId xmlns:a16="http://schemas.microsoft.com/office/drawing/2014/main" id="{EEB975A3-45AD-068A-4330-D697B7852512}"/>
+                </a:ext>
+              </a:extLst>
+            </p:cNvPr>
+            <p:cNvPicPr>
+              <a:picLocks noChangeAspect="1"/>
+            </p:cNvPicPr>
+            <p:nvPr/>
+          </p:nvPicPr>
+          <p:blipFill>
+            <a:blip r:embed="rId3"/>
+            <a:stretch>
+              <a:fillRect/>
+            </a:stretch>
+          </p:blipFill>
+          <p:spPr>
+            <a:xfrm>
+              <a:off x="5416515" y="2031044"/>
+              <a:ext cx="1358970" cy="539778"/>
+            </a:xfrm>
+            <a:prstGeom prst="rect">
+              <a:avLst/>
+            </a:prstGeom>
+          </p:spPr>
+        </p:pic>
+      </p:grpSp>
+      <p:sp>
+        <p:nvSpPr>
+          <p:cNvPr id="3" name="TextBox 2"/>
+          <p:cNvSpPr txBox="1"/>
+          <p:nvPr/>
+        </p:nvSpPr>
         <p:spPr>
           <a:xfrm>
-            <a:off x="0" y="0"/>
-            <a:ext cx="9144000" cy="6858000"/>
+            <a:off x="4719484" y="1915860"/>
+            <a:ext cx="2753032" cy="586488"/>
           </a:xfrm>
           <a:prstGeom prst="rect">
             <a:avLst/>
           </a:prstGeom>
+          <a:noFill/>
         </p:spPr>
-      </p:pic>
-      <p:sp>
-        <p:nvSpPr>
-          <p:cNvPr id="3" name="TextBox 2"/>
-          <p:cNvSpPr txBox="1"/>
-          <p:nvPr/>
-        </p:nvSpPr>
-        <p:spPr>
-          <a:xfrm>
-            <a:off x="2743200" y="1988819"/>
-            <a:ext cx="3657600" cy="617220"/>
-          </a:xfrm>
-          <a:prstGeom prst="rect">
-            <a:avLst/>
-          </a:prstGeom>
-          <a:solidFill>
-            <a:srgbClr val="F6FAFC"/>
-          </a:solidFill>
-          <a:ln>
-            <a:noFill/>
-          </a:ln>
-        </p:spPr>
-        <p:txBody>
-          <a:bodyPr wrap="square" lIns="0" rIns="0" tIns="0" bIns="0" anchor="ctr">
+        <p:txBody>
+          <a:bodyPr wrap="square" lIns="0" tIns="0" rIns="0" bIns="0" anchor="ctr">
             <a:spAutoFit/>
           </a:bodyPr>
           <a:lstStyle/>
           <a:p>
             <a:pPr algn="ctr"/>
             <a:r>
-              <a:rPr sz="4000" b="0" i="0">
+              <a:rPr sz="4400" b="1" i="0" dirty="0">
                 <a:solidFill>
                   <a:srgbClr val="1A1210"/>
                 </a:solidFill>
@@ -3278,8 +3455,8 @@
         </p:nvSpPr>
         <p:spPr>
           <a:xfrm>
-            <a:off x="2560320" y="3017520"/>
-            <a:ext cx="6217920" cy="617220"/>
+            <a:off x="2753032" y="3164852"/>
+            <a:ext cx="6882580" cy="547388"/>
           </a:xfrm>
           <a:prstGeom prst="rect">
             <a:avLst/>
@@ -3287,16 +3464,16 @@
           <a:noFill/>
         </p:spPr>
         <p:txBody>
-          <a:bodyPr wrap="square" lIns="0" rIns="0" tIns="0" bIns="0" anchor="ctr">
+          <a:bodyPr wrap="square" lIns="0" tIns="0" rIns="0" bIns="0" anchor="ctr">
             <a:spAutoFit/>
           </a:bodyPr>
           <a:lstStyle/>
           <a:p>
             <a:pPr algn="ctr"/>
             <a:r>
-              <a:rPr sz="2600" b="1" i="0">
+              <a:rPr sz="3200" b="1" i="0">
                 <a:solidFill>
-                  <a:srgbClr val="1A1210"/>
+                  <a:srgbClr val="4A3A2A"/>
                 </a:solidFill>
                 <a:latin typeface="Georgia"/>
               </a:rPr>
@@ -3313,8 +3490,8 @@
         </p:nvSpPr>
         <p:spPr>
           <a:xfrm>
-            <a:off x="2560320" y="4869180"/>
-            <a:ext cx="6217920" cy="342900"/>
+            <a:off x="2753032" y="4809201"/>
+            <a:ext cx="6882580" cy="469190"/>
           </a:xfrm>
           <a:prstGeom prst="rect">
             <a:avLst/>
@@ -3322,7 +3499,7 @@
           <a:noFill/>
         </p:spPr>
         <p:txBody>
-          <a:bodyPr wrap="square" lIns="0" rIns="0" tIns="0" bIns="0" anchor="ctr">
+          <a:bodyPr wrap="square" lIns="0" tIns="0" rIns="0" bIns="0" anchor="ctr">
             <a:spAutoFit/>
           </a:bodyPr>
           <a:lstStyle/>
@@ -3349,15 +3526,15 @@
           <p:nvPr/>
         </p:nvPicPr>
         <p:blipFill>
-          <a:blip r:embed="rId3"/>
+          <a:blip r:embed="rId4"/>
           <a:stretch>
             <a:fillRect/>
           </a:stretch>
         </p:blipFill>
         <p:spPr>
           <a:xfrm>
-            <a:off x="548640" y="2468880"/>
-            <a:ext cx="1920240" cy="2057400"/>
+            <a:off x="355951" y="2741310"/>
+            <a:ext cx="2657408" cy="2657408"/>
           </a:xfrm>
           <a:prstGeom prst="roundRect">
             <a:avLst>
@@ -3692,4 +3869,10 @@
   </a:objectDefaults>
   <a:extraClrSchemeLst/>
 </a:theme>
+</file>
+
+<file path=docMetadata/LabelInfo.xml><?xml version="1.0" encoding="utf-8"?>
+<clbl:labelList xmlns:clbl="http://schemas.microsoft.com/office/2020/mipLabelMetadata">
+  <clbl:label id="{f42aa342-8706-4288-bd11-ebb85995028c}" enabled="1" method="Standard" siteId="{72f988bf-86f1-41af-91ab-2d7cd011db47}" contentBits="0" removed="0"/>
+</clbl:labelList>
 </file>
</xml_diff>

<commit_message>
v3.16.0: bundled graduation template with fixed placeholder z-order
The 2-slide certificate template shipped as the bundled default now has {{Year}}, {{Name}}, and {{Note}} text placeholders stacked on top of the certificate background picture. Previously they lived at the bottom of the group's z-order, so the cert PNG visually covered the substituted text on every kid slide (text was in the output XML but hidden).

Co-authored-by: Copilot <223556219+Copilot@users.noreply.github.com>

Copilot-Session: da8a130f-d6ca-45dc-be45-25af7d7b3bd0
</commit_message>
<xml_diff>
--- a/src-tauri/resources/templates/graduation-template.pptx
+++ b/src-tauri/resources/templates/graduation-template.pptx
@@ -3099,10 +3099,10 @@
       </p:grpSpPr>
       <p:grpSp>
         <p:nvGrpSpPr>
-          <p:cNvPr id="10" name="Group 9">
+          <p:cNvPr id="3" name="Group 2">
             <a:extLst>
               <a:ext uri="{FF2B5EF4-FFF2-40B4-BE49-F238E27FC236}">
-                <a16:creationId xmlns:a16="http://schemas.microsoft.com/office/drawing/2014/main" id="{6CBA6391-5DA1-DE38-5E85-E2408D6E6918}"/>
+                <a16:creationId xmlns:a16="http://schemas.microsoft.com/office/drawing/2014/main" id="{52A598AE-0C5A-BF62-820B-C86D13057090}"/>
               </a:ext>
             </a:extLst>
           </p:cNvPr>
@@ -3111,18 +3111,18 @@
         </p:nvGrpSpPr>
         <p:grpSpPr>
           <a:xfrm>
-            <a:off x="98322" y="0"/>
+            <a:off x="0" y="0"/>
             <a:ext cx="12192000" cy="6858000"/>
-            <a:chOff x="98322" y="0"/>
+            <a:chOff x="0" y="0"/>
             <a:chExt cx="12192000" cy="6858000"/>
           </a:xfrm>
         </p:grpSpPr>
         <p:pic>
           <p:nvPicPr>
-            <p:cNvPr id="2" name="Picture 1" descr="certificate_bg.png">
+            <p:cNvPr id="12" name="Picture 11">
               <a:extLst>
                 <a:ext uri="{FF2B5EF4-FFF2-40B4-BE49-F238E27FC236}">
-                  <a16:creationId xmlns:a16="http://schemas.microsoft.com/office/drawing/2014/main" id="{D5B292ED-DE92-E7AA-F32B-2113FC628872}"/>
+                  <a16:creationId xmlns:a16="http://schemas.microsoft.com/office/drawing/2014/main" id="{9F61B56D-5361-9CED-786F-1AEFE2DFDF89}"/>
                 </a:ext>
               </a:extLst>
             </p:cNvPr>
@@ -3139,20 +3139,204 @@
           </p:blipFill>
           <p:spPr>
             <a:xfrm>
-              <a:off x="98322" y="0"/>
-              <a:ext cx="12192000" cy="6858000"/>
+              <a:off x="10344536" y="243802"/>
+              <a:ext cx="1483398" cy="1483398"/>
             </a:xfrm>
             <a:prstGeom prst="rect">
               <a:avLst/>
             </a:prstGeom>
           </p:spPr>
         </p:pic>
+        <p:grpSp>
+          <p:nvGrpSpPr>
+            <p:cNvPr id="13" name="Group 12">
+              <a:extLst>
+                <a:ext uri="{FF2B5EF4-FFF2-40B4-BE49-F238E27FC236}">
+                  <a16:creationId xmlns:a16="http://schemas.microsoft.com/office/drawing/2014/main" id="{6230E61F-2F0C-4911-D8C0-C32558621DCE}"/>
+                </a:ext>
+              </a:extLst>
+            </p:cNvPr>
+            <p:cNvGrpSpPr/>
+            <p:nvPr/>
+          </p:nvGrpSpPr>
+          <p:grpSpPr>
+            <a:xfrm>
+              <a:off x="0" y="0"/>
+              <a:ext cx="12192000" cy="6858000"/>
+              <a:chOff x="283130" y="0"/>
+              <a:chExt cx="11908870" cy="6858000"/>
+            </a:xfrm>
+          </p:grpSpPr>
+          <p:grpSp>
+            <p:nvGrpSpPr>
+              <p:cNvPr id="15" name="Group 14">
+                <a:extLst>
+                  <a:ext uri="{FF2B5EF4-FFF2-40B4-BE49-F238E27FC236}">
+                    <a16:creationId xmlns:a16="http://schemas.microsoft.com/office/drawing/2014/main" id="{758F888A-3CAE-CC2B-E70C-FB0E4A9F8655}"/>
+                  </a:ext>
+                </a:extLst>
+              </p:cNvPr>
+              <p:cNvGrpSpPr/>
+              <p:nvPr/>
+            </p:nvGrpSpPr>
+            <p:grpSpPr>
+              <a:xfrm>
+                <a:off x="283130" y="0"/>
+                <a:ext cx="11908870" cy="6858000"/>
+                <a:chOff x="283130" y="0"/>
+                <a:chExt cx="11908870" cy="6858000"/>
+              </a:xfrm>
+            </p:grpSpPr>
+            <p:grpSp>
+              <p:nvGrpSpPr>
+                <p:cNvPr id="17" name="Group 16">
+                  <a:extLst>
+                    <a:ext uri="{FF2B5EF4-FFF2-40B4-BE49-F238E27FC236}">
+                      <a16:creationId xmlns:a16="http://schemas.microsoft.com/office/drawing/2014/main" id="{50B7C2F7-D50D-318E-0CF8-890FA9B4E646}"/>
+                    </a:ext>
+                  </a:extLst>
+                </p:cNvPr>
+                <p:cNvGrpSpPr/>
+                <p:nvPr/>
+              </p:nvGrpSpPr>
+              <p:grpSpPr>
+                <a:xfrm>
+                  <a:off x="283130" y="0"/>
+                  <a:ext cx="11908870" cy="6858000"/>
+                  <a:chOff x="283130" y="0"/>
+                  <a:chExt cx="11908870" cy="6858000"/>
+                </a:xfrm>
+              </p:grpSpPr>
+              <p:pic>
+                <p:nvPicPr>
+                  <p:cNvPr id="19" name="Picture 18" descr="certificate_bg.png">
+                    <a:extLst>
+                      <a:ext uri="{FF2B5EF4-FFF2-40B4-BE49-F238E27FC236}">
+                        <a16:creationId xmlns:a16="http://schemas.microsoft.com/office/drawing/2014/main" id="{2F16778B-4E9D-0FFB-CFC2-ED642C59165E}"/>
+                      </a:ext>
+                    </a:extLst>
+                  </p:cNvPr>
+                  <p:cNvPicPr>
+                    <a:picLocks noChangeAspect="1"/>
+                  </p:cNvPicPr>
+                  <p:nvPr/>
+                </p:nvPicPr>
+                <p:blipFill>
+                  <a:blip r:embed="rId3"/>
+                  <a:srcRect l="2322"/>
+                  <a:stretch>
+                    <a:fillRect/>
+                  </a:stretch>
+                </p:blipFill>
+                <p:spPr>
+                  <a:xfrm>
+                    <a:off x="283130" y="0"/>
+                    <a:ext cx="11908870" cy="6858000"/>
+                  </a:xfrm>
+                  <a:prstGeom prst="rect">
+                    <a:avLst/>
+                  </a:prstGeom>
+                </p:spPr>
+              </p:pic>
+              <p:pic>
+                <p:nvPicPr>
+                  <p:cNvPr id="20" name="Picture 19">
+                    <a:extLst>
+                      <a:ext uri="{FF2B5EF4-FFF2-40B4-BE49-F238E27FC236}">
+                        <a16:creationId xmlns:a16="http://schemas.microsoft.com/office/drawing/2014/main" id="{E5FABAB8-D0D2-B42B-BA89-CD47481F46E3}"/>
+                      </a:ext>
+                    </a:extLst>
+                  </p:cNvPr>
+                  <p:cNvPicPr>
+                    <a:picLocks noChangeAspect="1"/>
+                  </p:cNvPicPr>
+                  <p:nvPr/>
+                </p:nvPicPr>
+                <p:blipFill>
+                  <a:blip r:embed="rId4"/>
+                  <a:stretch>
+                    <a:fillRect/>
+                  </a:stretch>
+                </p:blipFill>
+                <p:spPr>
+                  <a:xfrm>
+                    <a:off x="5416515" y="2031044"/>
+                    <a:ext cx="1358970" cy="539778"/>
+                  </a:xfrm>
+                  <a:prstGeom prst="rect">
+                    <a:avLst/>
+                  </a:prstGeom>
+                </p:spPr>
+              </p:pic>
+            </p:grpSp>
+            <p:pic>
+              <p:nvPicPr>
+                <p:cNvPr id="18" name="Picture 17">
+                  <a:extLst>
+                    <a:ext uri="{FF2B5EF4-FFF2-40B4-BE49-F238E27FC236}">
+                      <a16:creationId xmlns:a16="http://schemas.microsoft.com/office/drawing/2014/main" id="{5960937D-BEA8-0288-60B7-788EB7C60134}"/>
+                    </a:ext>
+                  </a:extLst>
+                </p:cNvPr>
+                <p:cNvPicPr>
+                  <a:picLocks noChangeAspect="1"/>
+                </p:cNvPicPr>
+                <p:nvPr/>
+              </p:nvPicPr>
+              <p:blipFill>
+                <a:blip r:embed="rId5"/>
+                <a:stretch>
+                  <a:fillRect/>
+                </a:stretch>
+              </p:blipFill>
+              <p:spPr>
+                <a:xfrm>
+                  <a:off x="9766300" y="165050"/>
+                  <a:ext cx="2269087" cy="1642583"/>
+                </a:xfrm>
+                <a:prstGeom prst="rect">
+                  <a:avLst/>
+                </a:prstGeom>
+              </p:spPr>
+            </p:pic>
+          </p:grpSp>
+          <p:pic>
+            <p:nvPicPr>
+              <p:cNvPr id="16" name="Picture 15">
+                <a:extLst>
+                  <a:ext uri="{FF2B5EF4-FFF2-40B4-BE49-F238E27FC236}">
+                    <a16:creationId xmlns:a16="http://schemas.microsoft.com/office/drawing/2014/main" id="{7EEB5C07-CC9B-CECD-465A-D5F57423B9FA}"/>
+                  </a:ext>
+                </a:extLst>
+              </p:cNvPr>
+              <p:cNvPicPr>
+                <a:picLocks noChangeAspect="1"/>
+              </p:cNvPicPr>
+              <p:nvPr/>
+            </p:nvPicPr>
+            <p:blipFill>
+              <a:blip r:embed="rId6"/>
+              <a:stretch>
+                <a:fillRect/>
+              </a:stretch>
+            </p:blipFill>
+            <p:spPr>
+              <a:xfrm>
+                <a:off x="283130" y="29634"/>
+                <a:ext cx="143844" cy="6802968"/>
+              </a:xfrm>
+              <a:prstGeom prst="rect">
+                <a:avLst/>
+              </a:prstGeom>
+            </p:spPr>
+          </p:pic>
+        </p:grpSp>
         <p:pic>
           <p:nvPicPr>
-            <p:cNvPr id="8" name="Picture 7">
+            <p:cNvPr id="14" name="Picture 13">
               <a:extLst>
                 <a:ext uri="{FF2B5EF4-FFF2-40B4-BE49-F238E27FC236}">
-                  <a16:creationId xmlns:a16="http://schemas.microsoft.com/office/drawing/2014/main" id="{5915D130-770F-5956-6D9C-F05C733AD5BF}"/>
+                  <a16:creationId xmlns:a16="http://schemas.microsoft.com/office/drawing/2014/main" id="{F10F8B6D-52AC-5632-EE55-36546F76ADE6}"/>
                 </a:ext>
               </a:extLst>
             </p:cNvPr>
@@ -3162,15 +3346,15 @@
             <p:nvPr/>
           </p:nvPicPr>
           <p:blipFill>
-            <a:blip r:embed="rId3"/>
+            <a:blip r:embed="rId2"/>
             <a:stretch>
               <a:fillRect/>
             </a:stretch>
           </p:blipFill>
           <p:spPr>
             <a:xfrm>
-              <a:off x="5416515" y="2031044"/>
-              <a:ext cx="1358970" cy="539778"/>
+              <a:off x="10545234" y="209935"/>
+              <a:ext cx="1282700" cy="1282700"/>
             </a:xfrm>
             <a:prstGeom prst="rect">
               <a:avLst/>
@@ -3333,10 +3517,10 @@
       </p:grpSpPr>
       <p:grpSp>
         <p:nvGrpSpPr>
-          <p:cNvPr id="7" name="Group 6">
+          <p:cNvPr id="22" name="Group 21">
             <a:extLst>
               <a:ext uri="{FF2B5EF4-FFF2-40B4-BE49-F238E27FC236}">
-                <a16:creationId xmlns:a16="http://schemas.microsoft.com/office/drawing/2014/main" id="{2C1E85EE-CA96-32D4-F78C-AB2BD0FB8249}"/>
+                <a16:creationId xmlns:a16="http://schemas.microsoft.com/office/drawing/2014/main" id="{DECC878E-3E04-CE57-7149-18F34945A71A}"/>
               </a:ext>
             </a:extLst>
           </p:cNvPr>
@@ -3353,10 +3537,10 @@
         </p:grpSpPr>
         <p:pic>
           <p:nvPicPr>
-            <p:cNvPr id="8" name="Picture 7" descr="certificate_bg.png">
+            <p:cNvPr id="14" name="Picture 13">
               <a:extLst>
                 <a:ext uri="{FF2B5EF4-FFF2-40B4-BE49-F238E27FC236}">
-                  <a16:creationId xmlns:a16="http://schemas.microsoft.com/office/drawing/2014/main" id="{4A58C1B1-FCCF-3E1C-6B13-3FD965491745}"/>
+                  <a16:creationId xmlns:a16="http://schemas.microsoft.com/office/drawing/2014/main" id="{B8A18792-CBAF-CB68-9B26-2ADB50F7EC15}"/>
                 </a:ext>
               </a:extLst>
             </p:cNvPr>
@@ -3373,20 +3557,204 @@
           </p:blipFill>
           <p:spPr>
             <a:xfrm>
-              <a:off x="0" y="0"/>
-              <a:ext cx="12192000" cy="6858000"/>
+              <a:off x="10344536" y="243802"/>
+              <a:ext cx="1483398" cy="1483398"/>
             </a:xfrm>
             <a:prstGeom prst="rect">
               <a:avLst/>
             </a:prstGeom>
           </p:spPr>
         </p:pic>
+        <p:grpSp>
+          <p:nvGrpSpPr>
+            <p:cNvPr id="19" name="Group 18">
+              <a:extLst>
+                <a:ext uri="{FF2B5EF4-FFF2-40B4-BE49-F238E27FC236}">
+                  <a16:creationId xmlns:a16="http://schemas.microsoft.com/office/drawing/2014/main" id="{72DDAC2A-2347-7C92-B9BA-56F1F727C2E8}"/>
+                </a:ext>
+              </a:extLst>
+            </p:cNvPr>
+            <p:cNvGrpSpPr/>
+            <p:nvPr/>
+          </p:nvGrpSpPr>
+          <p:grpSpPr>
+            <a:xfrm>
+              <a:off x="0" y="0"/>
+              <a:ext cx="12192000" cy="6858000"/>
+              <a:chOff x="283130" y="0"/>
+              <a:chExt cx="11908870" cy="6858000"/>
+            </a:xfrm>
+          </p:grpSpPr>
+          <p:grpSp>
+            <p:nvGrpSpPr>
+              <p:cNvPr id="12" name="Group 11">
+                <a:extLst>
+                  <a:ext uri="{FF2B5EF4-FFF2-40B4-BE49-F238E27FC236}">
+                    <a16:creationId xmlns:a16="http://schemas.microsoft.com/office/drawing/2014/main" id="{D85793ED-D4B4-8B00-47B4-DCFBE1409E44}"/>
+                  </a:ext>
+                </a:extLst>
+              </p:cNvPr>
+              <p:cNvGrpSpPr/>
+              <p:nvPr/>
+            </p:nvGrpSpPr>
+            <p:grpSpPr>
+              <a:xfrm>
+                <a:off x="283130" y="0"/>
+                <a:ext cx="11908870" cy="6858000"/>
+                <a:chOff x="283130" y="0"/>
+                <a:chExt cx="11908870" cy="6858000"/>
+              </a:xfrm>
+            </p:grpSpPr>
+            <p:grpSp>
+              <p:nvGrpSpPr>
+                <p:cNvPr id="7" name="Group 6">
+                  <a:extLst>
+                    <a:ext uri="{FF2B5EF4-FFF2-40B4-BE49-F238E27FC236}">
+                      <a16:creationId xmlns:a16="http://schemas.microsoft.com/office/drawing/2014/main" id="{2C1E85EE-CA96-32D4-F78C-AB2BD0FB8249}"/>
+                    </a:ext>
+                  </a:extLst>
+                </p:cNvPr>
+                <p:cNvGrpSpPr/>
+                <p:nvPr/>
+              </p:nvGrpSpPr>
+              <p:grpSpPr>
+                <a:xfrm>
+                  <a:off x="283130" y="0"/>
+                  <a:ext cx="11908870" cy="6858000"/>
+                  <a:chOff x="283130" y="0"/>
+                  <a:chExt cx="11908870" cy="6858000"/>
+                </a:xfrm>
+              </p:grpSpPr>
+              <p:pic>
+                <p:nvPicPr>
+                  <p:cNvPr id="8" name="Picture 7" descr="certificate_bg.png">
+                    <a:extLst>
+                      <a:ext uri="{FF2B5EF4-FFF2-40B4-BE49-F238E27FC236}">
+                        <a16:creationId xmlns:a16="http://schemas.microsoft.com/office/drawing/2014/main" id="{4A58C1B1-FCCF-3E1C-6B13-3FD965491745}"/>
+                      </a:ext>
+                    </a:extLst>
+                  </p:cNvPr>
+                  <p:cNvPicPr>
+                    <a:picLocks noChangeAspect="1"/>
+                  </p:cNvPicPr>
+                  <p:nvPr/>
+                </p:nvPicPr>
+                <p:blipFill>
+                  <a:blip r:embed="rId3"/>
+                  <a:srcRect l="2322"/>
+                  <a:stretch>
+                    <a:fillRect/>
+                  </a:stretch>
+                </p:blipFill>
+                <p:spPr>
+                  <a:xfrm>
+                    <a:off x="283130" y="0"/>
+                    <a:ext cx="11908870" cy="6858000"/>
+                  </a:xfrm>
+                  <a:prstGeom prst="rect">
+                    <a:avLst/>
+                  </a:prstGeom>
+                </p:spPr>
+              </p:pic>
+              <p:pic>
+                <p:nvPicPr>
+                  <p:cNvPr id="9" name="Picture 8">
+                    <a:extLst>
+                      <a:ext uri="{FF2B5EF4-FFF2-40B4-BE49-F238E27FC236}">
+                        <a16:creationId xmlns:a16="http://schemas.microsoft.com/office/drawing/2014/main" id="{EEB975A3-45AD-068A-4330-D697B7852512}"/>
+                      </a:ext>
+                    </a:extLst>
+                  </p:cNvPr>
+                  <p:cNvPicPr>
+                    <a:picLocks noChangeAspect="1"/>
+                  </p:cNvPicPr>
+                  <p:nvPr/>
+                </p:nvPicPr>
+                <p:blipFill>
+                  <a:blip r:embed="rId4"/>
+                  <a:stretch>
+                    <a:fillRect/>
+                  </a:stretch>
+                </p:blipFill>
+                <p:spPr>
+                  <a:xfrm>
+                    <a:off x="5416515" y="2031044"/>
+                    <a:ext cx="1358970" cy="539778"/>
+                  </a:xfrm>
+                  <a:prstGeom prst="rect">
+                    <a:avLst/>
+                  </a:prstGeom>
+                </p:spPr>
+              </p:pic>
+            </p:grpSp>
+            <p:pic>
+              <p:nvPicPr>
+                <p:cNvPr id="10" name="Picture 9">
+                  <a:extLst>
+                    <a:ext uri="{FF2B5EF4-FFF2-40B4-BE49-F238E27FC236}">
+                      <a16:creationId xmlns:a16="http://schemas.microsoft.com/office/drawing/2014/main" id="{012A5A37-7AE9-0433-77CE-38351475530F}"/>
+                    </a:ext>
+                  </a:extLst>
+                </p:cNvPr>
+                <p:cNvPicPr>
+                  <a:picLocks noChangeAspect="1"/>
+                </p:cNvPicPr>
+                <p:nvPr/>
+              </p:nvPicPr>
+              <p:blipFill>
+                <a:blip r:embed="rId5"/>
+                <a:stretch>
+                  <a:fillRect/>
+                </a:stretch>
+              </p:blipFill>
+              <p:spPr>
+                <a:xfrm>
+                  <a:off x="9766300" y="165050"/>
+                  <a:ext cx="2269087" cy="1642583"/>
+                </a:xfrm>
+                <a:prstGeom prst="rect">
+                  <a:avLst/>
+                </a:prstGeom>
+              </p:spPr>
+            </p:pic>
+          </p:grpSp>
+          <p:pic>
+            <p:nvPicPr>
+              <p:cNvPr id="18" name="Picture 17">
+                <a:extLst>
+                  <a:ext uri="{FF2B5EF4-FFF2-40B4-BE49-F238E27FC236}">
+                    <a16:creationId xmlns:a16="http://schemas.microsoft.com/office/drawing/2014/main" id="{A9793414-6E95-D085-1F66-AE0777FBA14C}"/>
+                  </a:ext>
+                </a:extLst>
+              </p:cNvPr>
+              <p:cNvPicPr>
+                <a:picLocks noChangeAspect="1"/>
+              </p:cNvPicPr>
+              <p:nvPr/>
+            </p:nvPicPr>
+            <p:blipFill>
+              <a:blip r:embed="rId6"/>
+              <a:stretch>
+                <a:fillRect/>
+              </a:stretch>
+            </p:blipFill>
+            <p:spPr>
+              <a:xfrm>
+                <a:off x="283130" y="29634"/>
+                <a:ext cx="143844" cy="6802968"/>
+              </a:xfrm>
+              <a:prstGeom prst="rect">
+                <a:avLst/>
+              </a:prstGeom>
+            </p:spPr>
+          </p:pic>
+        </p:grpSp>
         <p:pic>
           <p:nvPicPr>
-            <p:cNvPr id="9" name="Picture 8">
+            <p:cNvPr id="21" name="Picture 20">
               <a:extLst>
                 <a:ext uri="{FF2B5EF4-FFF2-40B4-BE49-F238E27FC236}">
-                  <a16:creationId xmlns:a16="http://schemas.microsoft.com/office/drawing/2014/main" id="{EEB975A3-45AD-068A-4330-D697B7852512}"/>
+                  <a16:creationId xmlns:a16="http://schemas.microsoft.com/office/drawing/2014/main" id="{1FFDB62D-B7D6-D91A-9864-C55B95678D6E}"/>
                 </a:ext>
               </a:extLst>
             </p:cNvPr>
@@ -3396,127 +3764,127 @@
             <p:nvPr/>
           </p:nvPicPr>
           <p:blipFill>
-            <a:blip r:embed="rId3"/>
+            <a:blip r:embed="rId2"/>
             <a:stretch>
               <a:fillRect/>
             </a:stretch>
           </p:blipFill>
           <p:spPr>
             <a:xfrm>
-              <a:off x="5416515" y="2031044"/>
-              <a:ext cx="1358970" cy="539778"/>
+              <a:off x="10545234" y="209935"/>
+              <a:ext cx="1282700" cy="1282700"/>
             </a:xfrm>
             <a:prstGeom prst="rect">
               <a:avLst/>
             </a:prstGeom>
           </p:spPr>
         </p:pic>
+        <p:sp>
+          <p:nvSpPr>
+            <p:cNvPr id="3" name="TextBox 2"/>
+            <p:cNvSpPr txBox="1"/>
+            <p:nvPr/>
+          </p:nvSpPr>
+          <p:spPr>
+            <a:xfrm>
+              <a:off x="4719484" y="1915860"/>
+              <a:ext cx="2753032" cy="586488"/>
+            </a:xfrm>
+            <a:prstGeom prst="rect">
+              <a:avLst/>
+            </a:prstGeom>
+            <a:noFill/>
+          </p:spPr>
+          <p:txBody>
+            <a:bodyPr wrap="square" lIns="0" tIns="0" rIns="0" bIns="0" anchor="ctr">
+              <a:spAutoFit/>
+            </a:bodyPr>
+            <a:lstStyle/>
+            <a:p>
+              <a:pPr algn="ctr"/>
+              <a:r>
+                <a:rPr sz="4400" b="1" i="0" dirty="0">
+                  <a:solidFill>
+                    <a:srgbClr val="1A1210"/>
+                  </a:solidFill>
+                  <a:latin typeface="Georgia"/>
+                </a:rPr>
+                <a:t>{{Year}}</a:t>
+              </a:r>
+            </a:p>
+          </p:txBody>
+        </p:sp>
+        <p:sp>
+          <p:nvSpPr>
+            <p:cNvPr id="4" name="TextBox 3"/>
+            <p:cNvSpPr txBox="1"/>
+            <p:nvPr/>
+          </p:nvSpPr>
+          <p:spPr>
+            <a:xfrm>
+              <a:off x="2753032" y="3164852"/>
+              <a:ext cx="6882580" cy="547388"/>
+            </a:xfrm>
+            <a:prstGeom prst="rect">
+              <a:avLst/>
+            </a:prstGeom>
+            <a:noFill/>
+          </p:spPr>
+          <p:txBody>
+            <a:bodyPr wrap="square" lIns="0" tIns="0" rIns="0" bIns="0" anchor="ctr">
+              <a:spAutoFit/>
+            </a:bodyPr>
+            <a:lstStyle/>
+            <a:p>
+              <a:pPr algn="ctr"/>
+              <a:r>
+                <a:rPr sz="3200" b="1" i="0">
+                  <a:solidFill>
+                    <a:srgbClr val="4A3A2A"/>
+                  </a:solidFill>
+                  <a:latin typeface="Georgia"/>
+                </a:rPr>
+                <a:t>{{Name}}</a:t>
+              </a:r>
+            </a:p>
+          </p:txBody>
+        </p:sp>
+        <p:sp>
+          <p:nvSpPr>
+            <p:cNvPr id="5" name="TextBox 4"/>
+            <p:cNvSpPr txBox="1"/>
+            <p:nvPr/>
+          </p:nvSpPr>
+          <p:spPr>
+            <a:xfrm>
+              <a:off x="2753032" y="4809201"/>
+              <a:ext cx="6882580" cy="469190"/>
+            </a:xfrm>
+            <a:prstGeom prst="rect">
+              <a:avLst/>
+            </a:prstGeom>
+            <a:noFill/>
+          </p:spPr>
+          <p:txBody>
+            <a:bodyPr wrap="square" lIns="0" tIns="0" rIns="0" bIns="0" anchor="ctr">
+              <a:spAutoFit/>
+            </a:bodyPr>
+            <a:lstStyle/>
+            <a:p>
+              <a:pPr algn="ctr"/>
+              <a:r>
+                <a:rPr sz="1300" b="0" i="1">
+                  <a:solidFill>
+                    <a:srgbClr val="554538"/>
+                  </a:solidFill>
+                  <a:latin typeface="Calibri"/>
+                </a:rPr>
+                <a:t>{{Note}}</a:t>
+              </a:r>
+            </a:p>
+          </p:txBody>
+        </p:sp>
       </p:grpSp>
-      <p:sp>
-        <p:nvSpPr>
-          <p:cNvPr id="3" name="TextBox 2"/>
-          <p:cNvSpPr txBox="1"/>
-          <p:nvPr/>
-        </p:nvSpPr>
-        <p:spPr>
-          <a:xfrm>
-            <a:off x="4719484" y="1915860"/>
-            <a:ext cx="2753032" cy="586488"/>
-          </a:xfrm>
-          <a:prstGeom prst="rect">
-            <a:avLst/>
-          </a:prstGeom>
-          <a:noFill/>
-        </p:spPr>
-        <p:txBody>
-          <a:bodyPr wrap="square" lIns="0" tIns="0" rIns="0" bIns="0" anchor="ctr">
-            <a:spAutoFit/>
-          </a:bodyPr>
-          <a:lstStyle/>
-          <a:p>
-            <a:pPr algn="ctr"/>
-            <a:r>
-              <a:rPr sz="4400" b="1" i="0" dirty="0">
-                <a:solidFill>
-                  <a:srgbClr val="1A1210"/>
-                </a:solidFill>
-                <a:latin typeface="Georgia"/>
-              </a:rPr>
-              <a:t>{{Year}}</a:t>
-            </a:r>
-          </a:p>
-        </p:txBody>
-      </p:sp>
-      <p:sp>
-        <p:nvSpPr>
-          <p:cNvPr id="4" name="TextBox 3"/>
-          <p:cNvSpPr txBox="1"/>
-          <p:nvPr/>
-        </p:nvSpPr>
-        <p:spPr>
-          <a:xfrm>
-            <a:off x="2753032" y="3164852"/>
-            <a:ext cx="6882580" cy="547388"/>
-          </a:xfrm>
-          <a:prstGeom prst="rect">
-            <a:avLst/>
-          </a:prstGeom>
-          <a:noFill/>
-        </p:spPr>
-        <p:txBody>
-          <a:bodyPr wrap="square" lIns="0" tIns="0" rIns="0" bIns="0" anchor="ctr">
-            <a:spAutoFit/>
-          </a:bodyPr>
-          <a:lstStyle/>
-          <a:p>
-            <a:pPr algn="ctr"/>
-            <a:r>
-              <a:rPr sz="3200" b="1" i="0">
-                <a:solidFill>
-                  <a:srgbClr val="4A3A2A"/>
-                </a:solidFill>
-                <a:latin typeface="Georgia"/>
-              </a:rPr>
-              <a:t>{{Name}}</a:t>
-            </a:r>
-          </a:p>
-        </p:txBody>
-      </p:sp>
-      <p:sp>
-        <p:nvSpPr>
-          <p:cNvPr id="5" name="TextBox 4"/>
-          <p:cNvSpPr txBox="1"/>
-          <p:nvPr/>
-        </p:nvSpPr>
-        <p:spPr>
-          <a:xfrm>
-            <a:off x="2753032" y="4809201"/>
-            <a:ext cx="6882580" cy="469190"/>
-          </a:xfrm>
-          <a:prstGeom prst="rect">
-            <a:avLst/>
-          </a:prstGeom>
-          <a:noFill/>
-        </p:spPr>
-        <p:txBody>
-          <a:bodyPr wrap="square" lIns="0" tIns="0" rIns="0" bIns="0" anchor="ctr">
-            <a:spAutoFit/>
-          </a:bodyPr>
-          <a:lstStyle/>
-          <a:p>
-            <a:pPr algn="ctr"/>
-            <a:r>
-              <a:rPr sz="1300" b="0" i="1">
-                <a:solidFill>
-                  <a:srgbClr val="554538"/>
-                </a:solidFill>
-                <a:latin typeface="Calibri"/>
-              </a:rPr>
-              <a:t>{{Note}}</a:t>
-            </a:r>
-          </a:p>
-        </p:txBody>
-      </p:sp>
       <p:pic>
         <p:nvPicPr>
           <p:cNvPr id="6" name="Picture 5" descr="{{Photo}}" title="Student Photo"/>
@@ -3526,15 +3894,15 @@
           <p:nvPr/>
         </p:nvPicPr>
         <p:blipFill>
-          <a:blip r:embed="rId4"/>
+          <a:blip r:embed="rId7"/>
           <a:stretch>
             <a:fillRect/>
           </a:stretch>
         </p:blipFill>
         <p:spPr>
           <a:xfrm>
-            <a:off x="355951" y="2741310"/>
-            <a:ext cx="2657408" cy="2657408"/>
+            <a:off x="743182" y="2383536"/>
+            <a:ext cx="2068494" cy="2657408"/>
           </a:xfrm>
           <a:prstGeom prst="roundRect">
             <a:avLst>

</xml_diff>